<commit_message>
Round 20an: project flowchart, and the gate and archive counts it exposed
</commit_message>
<xml_diff>
--- a/重构版论文_v4_20260915/汇报用_论文介绍.pptx
+++ b/重构版论文_v4_20260915/汇报用_论文介绍.pptx
@@ -649,7 +649,7 @@
           <a:lstStyle/>
           <a:p>
             <a:r>
-              <a:t>六阶段审计的每一步都有计数与产物记录；外部三个语料是独立原生标签基准；主实验十个种子。特别强调：46 项检查与逐样本预测都公开，审稿时可直接重算。</a:t>
+              <a:t>六阶段审计的每一步都有计数与产物记录；外部三个语料是独立原生标签基准；主实验十个种子。特别强调：49 项检查与逐样本预测都公开，审稿时可直接重算。</a:t>
             </a:r>
           </a:p>
         </p:txBody>
@@ -6672,7 +6672,7 @@
                 </a:solidFill>
                 <a:latin typeface="Microsoft YaHei"/>
               </a:rPr>
-              <a:t>46 项自动检查全绿；722 个逐样本预测公开；仓库带 tag v1.11.0</a:t>
+              <a:t>49 项自动检查全绿；722 个逐样本预测公开；仓库带 tag v1.11.0</a:t>
             </a:r>
           </a:p>
         </p:txBody>
@@ -9605,7 +9605,7 @@
                 </a:solidFill>
                 <a:latin typeface="Microsoft YaHei"/>
               </a:rPr>
-              <a:t>45 项自动检查持续复核这些数字；开放集与代价的每一项都能从公开的逐样本预测重算。</a:t>
+              <a:t>49 项自动检查持续复核这些数字；开放集与代价的每一项都能从公开的逐样本预测重算。</a:t>
             </a:r>
           </a:p>
         </p:txBody>

</xml_diff>

<commit_message>
Round 20ap: experiment record - 18 experiments with code, run logs and rendered evidence
</commit_message>
<xml_diff>
--- a/重构版论文_v4_20260915/汇报用_论文介绍.pptx
+++ b/重构版论文_v4_20260915/汇报用_论文介绍.pptx
@@ -863,7 +863,7 @@
           <a:lstStyle/>
           <a:p>
             <a:r>
-              <a:t>六阶段审计的每一步都有计数与产物记录；外部三个语料是独立原生标签基准；主实验十个种子。特别强调：49 项检查与逐样本预测都公开，审稿时可直接重算。</a:t>
+              <a:t>六阶段审计的每一步都有计数与产物记录；外部三个语料是独立原生标签基准；主实验十个种子。特别强调：50 项检查与逐样本预测都公开，审稿时可直接重算。</a:t>
             </a:r>
           </a:p>
         </p:txBody>
@@ -6863,7 +6863,7 @@
                 </a:solidFill>
                 <a:latin typeface="Microsoft YaHei"/>
               </a:rPr>
-              <a:t>仓库：v1.11.0 标签 · 逐样本预测 722 个 · 补充材料 S01–S30 · 投稿包 154 个文件</a:t>
+              <a:t>仓库：v1.11.0 标签 · 逐样本预测 722 个 · 补充材料 S01–S30 · 投稿包 213 个文件</a:t>
             </a:r>
           </a:p>
         </p:txBody>
@@ -6948,7 +6948,7 @@
                 </a:solidFill>
                 <a:latin typeface="Microsoft YaHei"/>
               </a:rPr>
-              <a:t>49 项自动检查覆盖四类风险：</a:t>
+              <a:t>50 项自动检查覆盖四类风险：</a:t>
             </a:r>
           </a:p>
           <a:p>
@@ -9147,7 +9147,7 @@
                 </a:solidFill>
                 <a:latin typeface="Microsoft YaHei"/>
               </a:rPr>
-              <a:t>49 项自动检查全绿；722 个逐样本预测公开；仓库带 tag v1.11.0</a:t>
+              <a:t>50 项自动检查全绿；722 个逐样本预测公开；仓库带 tag v1.11.0</a:t>
             </a:r>
           </a:p>
         </p:txBody>
@@ -13039,7 +13039,7 @@
                 </a:solidFill>
                 <a:latin typeface="Microsoft YaHei"/>
               </a:rPr>
-              <a:t>49 项自动检查持续复核这些数字；开放集与代价的每一项都能从公开的逐样本预测重算。</a:t>
+              <a:t>50 项自动检查持续复核这些数字；开放集与代价的每一项都能从公开的逐样本预测重算。</a:t>
             </a:r>
           </a:p>
         </p:txBody>

</xml_diff>

<commit_message>
Round 20ar: material completeness index - every project item mapped to the bundle or its reason
</commit_message>
<xml_diff>
--- a/重构版论文_v4_20260915/汇报用_论文介绍.pptx
+++ b/重构版论文_v4_20260915/汇报用_论文介绍.pptx
@@ -863,7 +863,7 @@
           <a:lstStyle/>
           <a:p>
             <a:r>
-              <a:t>六阶段审计的每一步都有计数与产物记录；外部三个语料是独立原生标签基准；主实验十个种子。特别强调：50 项检查与逐样本预测都公开，审稿时可直接重算。</a:t>
+              <a:t>六阶段审计的每一步都有计数与产物记录；外部三个语料是独立原生标签基准；主实验十个种子。特别强调：51 项检查与逐样本预测都公开，审稿时可直接重算。</a:t>
             </a:r>
           </a:p>
         </p:txBody>
@@ -6863,7 +6863,7 @@
                 </a:solidFill>
                 <a:latin typeface="Microsoft YaHei"/>
               </a:rPr>
-              <a:t>仓库：v1.11.0 标签 · 逐样本预测 722 个 · 补充材料 S01–S30 · 投稿包 213 个文件</a:t>
+              <a:t>仓库：v1.11.0 标签 · 逐样本预测 722 个 · 补充材料 S01–S30 · 投稿包 781 个文件</a:t>
             </a:r>
           </a:p>
         </p:txBody>
@@ -6948,7 +6948,7 @@
                 </a:solidFill>
                 <a:latin typeface="Microsoft YaHei"/>
               </a:rPr>
-              <a:t>50 项自动检查覆盖四类风险：</a:t>
+              <a:t>51 项自动检查覆盖四类风险：</a:t>
             </a:r>
           </a:p>
           <a:p>
@@ -9147,7 +9147,7 @@
                 </a:solidFill>
                 <a:latin typeface="Microsoft YaHei"/>
               </a:rPr>
-              <a:t>50 项自动检查全绿；722 个逐样本预测公开；仓库带 tag v1.11.0</a:t>
+              <a:t>51 项自动检查全绿；722 个逐样本预测公开；仓库带 tag v1.11.0</a:t>
             </a:r>
           </a:p>
         </p:txBody>
@@ -13039,7 +13039,7 @@
                 </a:solidFill>
                 <a:latin typeface="Microsoft YaHei"/>
               </a:rPr>
-              <a:t>50 项自动检查持续复核这些数字；开放集与代价的每一项都能从公开的逐样本预测重算。</a:t>
+              <a:t>51 项自动检查持续复核这些数字；开放集与代价的每一项都能从公开的逐样本预测重算。</a:t>
             </a:r>
           </a:p>
         </p:txBody>

</xml_diff>

<commit_message>
Round 20as: data-products inventory - row counts and hashes for every local dataset
</commit_message>
<xml_diff>
--- a/重构版论文_v4_20260915/汇报用_论文介绍.pptx
+++ b/重构版论文_v4_20260915/汇报用_论文介绍.pptx
@@ -863,7 +863,7 @@
           <a:lstStyle/>
           <a:p>
             <a:r>
-              <a:t>六阶段审计的每一步都有计数与产物记录；外部三个语料是独立原生标签基准；主实验十个种子。特别强调：51 项检查与逐样本预测都公开，审稿时可直接重算。</a:t>
+              <a:t>六阶段审计的每一步都有计数与产物记录；外部三个语料是独立原生标签基准；主实验十个种子。特别强调：52 项检查与逐样本预测都公开，审稿时可直接重算。</a:t>
             </a:r>
           </a:p>
         </p:txBody>
@@ -6863,7 +6863,7 @@
                 </a:solidFill>
                 <a:latin typeface="Microsoft YaHei"/>
               </a:rPr>
-              <a:t>仓库：v1.11.0 标签 · 逐样本预测 722 个 · 补充材料 S01–S30 · 投稿包 781 个文件</a:t>
+              <a:t>仓库：v1.11.0 标签 · 逐样本预测 722 个 · 补充材料 S01–S30 · 投稿包 787 个文件</a:t>
             </a:r>
           </a:p>
         </p:txBody>
@@ -6948,7 +6948,7 @@
                 </a:solidFill>
                 <a:latin typeface="Microsoft YaHei"/>
               </a:rPr>
-              <a:t>51 项自动检查覆盖四类风险：</a:t>
+              <a:t>52 项自动检查覆盖四类风险：</a:t>
             </a:r>
           </a:p>
           <a:p>
@@ -9147,7 +9147,7 @@
                 </a:solidFill>
                 <a:latin typeface="Microsoft YaHei"/>
               </a:rPr>
-              <a:t>51 项自动检查全绿；722 个逐样本预测公开；仓库带 tag v1.11.0</a:t>
+              <a:t>52 项自动检查全绿；722 个逐样本预测公开；仓库带 tag v1.11.0</a:t>
             </a:r>
           </a:p>
         </p:txBody>
@@ -13039,7 +13039,7 @@
                 </a:solidFill>
                 <a:latin typeface="Microsoft YaHei"/>
               </a:rPr>
-              <a:t>51 项自动检查持续复核这些数字；开放集与代价的每一项都能从公开的逐样本预测重算。</a:t>
+              <a:t>52 项自动检查持续复核这些数字；开放集与代价的每一项都能从公开的逐样本预测重算。</a:t>
             </a:r>
           </a:p>
         </p:txBody>

</xml_diff>

<commit_message>
Round 20av: diversity claim stated as association; every cost figure carries its source
</commit_message>
<xml_diff>
--- a/重构版论文_v4_20260915/汇报用_论文介绍.pptx
+++ b/重构版论文_v4_20260915/汇报用_论文介绍.pptx
@@ -6863,7 +6863,7 @@
                 </a:solidFill>
                 <a:latin typeface="Microsoft YaHei"/>
               </a:rPr>
-              <a:t>仓库：v1.11.0 标签 · 逐样本预测 722 个 · 补充材料 S01–S30 · 投稿包 787 个文件</a:t>
+              <a:t>仓库：v1.11.0 标签 · 逐样本预测 722 个 · 补充材料 S01–S30 · 投稿包 793 个文件</a:t>
             </a:r>
           </a:p>
         </p:txBody>
@@ -11728,7 +11728,7 @@
                 </a:solidFill>
                 <a:latin typeface="Microsoft YaHei"/>
               </a:rPr>
-              <a:t>增益由专家多样性支配：分歧率 0.20%–0.36% 的专家集合 6 次运行增益恰好为 0；刻意去相关的三类集合 9 次运行全为正（斜率 0.0646，r = 0.749）。</a:t>
+              <a:t>增益与专家多样性同步变化（十五个配置的剂量—反应，属相关性证据）：分歧率 0.20%–0.36% 的专家集合 6 次运行增益恰好为 0；刻意去相关的三类集合 9 次运行全为正（斜率 0.0646，r = 0.749）。</a:t>
             </a:r>
           </a:p>
         </p:txBody>
@@ -12647,7 +12647,7 @@
                 </a:solidFill>
                 <a:latin typeface="Microsoft YaHei"/>
               </a:rPr>
-              <a:t>截断约 80 倍，全语料 175 倍</a:t>
+              <a:t>截断约 80 倍，全语料 175 倍（十种子均值）</a:t>
             </a:r>
           </a:p>
         </p:txBody>
@@ -12725,7 +12725,7 @@
                 </a:solidFill>
                 <a:latin typeface="Microsoft YaHei"/>
               </a:rPr>
-              <a:t>4.1 倍（9.09 MB vs 2.21 MB）</a:t>
+              <a:t>4.1 倍（9.09 MB vs 2.21 MB，单种子画像）</a:t>
             </a:r>
           </a:p>
         </p:txBody>

</xml_diff>

<commit_message>
Round 20ay: six extension experiments - member families, day holdout, 10-seed external benchmarks, deployment metrics, CIC-IDS2018 and CIC-IoT-2023
</commit_message>
<xml_diff>
--- a/重构版论文_v4_20260915/汇报用_论文介绍.pptx
+++ b/重构版论文_v4_20260915/汇报用_论文介绍.pptx
@@ -863,7 +863,7 @@
           <a:lstStyle/>
           <a:p>
             <a:r>
-              <a:t>六阶段审计的每一步都有计数与产物记录；外部三个语料是独立原生标签基准；主实验十个种子。特别强调：52 项检查与逐样本预测都公开，审稿时可直接重算。</a:t>
+              <a:t>六阶段审计的每一步都有计数与产物记录；外部三个语料是独立原生标签基准；主实验十个种子。特别强调：53 项检查与逐样本预测都公开，审稿时可直接重算。</a:t>
             </a:r>
           </a:p>
         </p:txBody>
@@ -6863,7 +6863,7 @@
                 </a:solidFill>
                 <a:latin typeface="Microsoft YaHei"/>
               </a:rPr>
-              <a:t>仓库：v1.11.0 标签 · 逐样本预测 722 个 · 补充材料 S01–S30 · 投稿包 793 个文件</a:t>
+              <a:t>仓库：v1.11.0 标签 · 逐样本预测 722 个 · 补充材料 S01–S30 · 投稿包 829 个文件</a:t>
             </a:r>
           </a:p>
         </p:txBody>
@@ -6948,7 +6948,7 @@
                 </a:solidFill>
                 <a:latin typeface="Microsoft YaHei"/>
               </a:rPr>
-              <a:t>52 项自动检查覆盖四类风险：</a:t>
+              <a:t>53 项自动检查覆盖四类风险：</a:t>
             </a:r>
           </a:p>
           <a:p>
@@ -9147,7 +9147,7 @@
                 </a:solidFill>
                 <a:latin typeface="Microsoft YaHei"/>
               </a:rPr>
-              <a:t>52 项自动检查全绿；722 个逐样本预测公开；仓库带 tag v1.11.0</a:t>
+              <a:t>53 项自动检查全绿；722 个逐样本预测公开；仓库带 tag v1.11.0</a:t>
             </a:r>
           </a:p>
         </p:txBody>
@@ -13039,7 +13039,7 @@
                 </a:solidFill>
                 <a:latin typeface="Microsoft YaHei"/>
               </a:rPr>
-              <a:t>52 项自动检查持续复核这些数字；开放集与代价的每一项都能从公开的逐样本预测重算。</a:t>
+              <a:t>53 项自动检查持续复核这些数字；开放集与代价的每一项都能从公开的逐样本预测重算。</a:t>
             </a:r>
           </a:p>
         </p:txBody>

</xml_diff>

<commit_message>
Round 20be: briefings and deck now state the thirteen corpora, the 2025 evidence and a recency Q&A
</commit_message>
<xml_diff>
--- a/重构版论文_v4_20260915/汇报用_论文介绍.pptx
+++ b/重构版论文_v4_20260915/汇报用_论文介绍.pptx
@@ -6863,7 +6863,7 @@
                 </a:solidFill>
                 <a:latin typeface="Microsoft YaHei"/>
               </a:rPr>
-              <a:t>仓库：v1.11.0 标签 · 逐样本预测 722 个 · 补充材料 S01–S30 · 投稿包 854 个文件</a:t>
+              <a:t>仓库：v1.11.0 标签 · 逐样本预测 722 个 · 补充材料 S01–S30 · 投稿包 873 个文件</a:t>
             </a:r>
           </a:p>
         </p:txBody>
@@ -8008,7 +8008,7 @@
                 </a:solidFill>
                 <a:latin typeface="Microsoft YaHei"/>
               </a:rPr>
-              <a:t>六阶段审计 + 四个语料 + 十个种子</a:t>
+              <a:t>六阶段审计 + 13 个语料 + 十个种子</a:t>
             </a:r>
           </a:p>
         </p:txBody>
@@ -13938,7 +13938,23 @@
                 </a:solidFill>
                 <a:latin typeface="Microsoft YaHei"/>
               </a:rPr>
-              <a:t>· 三个外部语料用各自原生标签，不重采样、不跨语料迁移，因此只能作为「结论方向不随语料改变」的旁证，不能当作迁移实验。</a:t>
+              <a:t>· 三个外部语料用各自原生标签，不重采样、不跨语料迁移，因此只能作为「结论方向不随语料改变」的旁证，不能当作迁移实验；</a:t>
+            </a:r>
+          </a:p>
+          <a:p>
+            <a:pPr algn="l">
+              <a:lnSpc>
+                <a:spcPct val="135000"/>
+              </a:lnSpc>
+            </a:pPr>
+            <a:r>
+              <a:rPr sz="1300" b="0">
+                <a:solidFill>
+                  <a:srgbClr val="1F2A37"/>
+                </a:solidFill>
+                <a:latin typeface="Microsoft YaHei"/>
+              </a:rPr>
+              <a:t>· 语料年代：13 个语料里八个发布于 2020 年及以后，其中三份发布于 2025 年，差值与上表同量级（见《向老师汇报要点》Q5）。</a:t>
             </a:r>
           </a:p>
         </p:txBody>

</xml_diff>

<commit_message>
Round 20bf: Gotham-2025 (packet-level, 18 classes) integrated - inert at the full budget, +0.0063 at 8/16 features
</commit_message>
<xml_diff>
--- a/重构版论文_v4_20260915/汇报用_论文介绍.pptx
+++ b/重构版论文_v4_20260915/汇报用_论文介绍.pptx
@@ -6863,7 +6863,7 @@
                 </a:solidFill>
                 <a:latin typeface="Microsoft YaHei"/>
               </a:rPr>
-              <a:t>仓库：v1.11.0 标签 · 逐样本预测 722 个 · 补充材料 S01–S30 · 投稿包 873 个文件</a:t>
+              <a:t>仓库：v1.11.0 标签 · 逐样本预测 722 个 · 补充材料 S01–S30 · 投稿包 884 个文件</a:t>
             </a:r>
           </a:p>
         </p:txBody>
@@ -8008,7 +8008,7 @@
                 </a:solidFill>
                 <a:latin typeface="Microsoft YaHei"/>
               </a:rPr>
-              <a:t>六阶段审计 + 13 个语料 + 十个种子</a:t>
+              <a:t>六阶段审计 + 14 个语料 + 十个种子</a:t>
             </a:r>
           </a:p>
         </p:txBody>
@@ -13954,7 +13954,23 @@
                 </a:solidFill>
                 <a:latin typeface="Microsoft YaHei"/>
               </a:rPr>
-              <a:t>· 语料年代：13 个语料里八个发布于 2020 年及以后，其中三份发布于 2025 年，差值与上表同量级（见《向老师汇报要点》Q5）。</a:t>
+              <a:t>· 语料年代：14 个语料里八个发布于 2020 年及以后，其中四份发布于 2025 年，差值与上表同量级（见《向老师汇报要点》Q5）；</a:t>
+            </a:r>
+          </a:p>
+          <a:p>
+            <a:pPr algn="l">
+              <a:lnSpc>
+                <a:spcPct val="135000"/>
+              </a:lnSpc>
+            </a:pPr>
+            <a:r>
+              <a:rPr sz="1300" b="0">
+                <a:solidFill>
+                  <a:srgbClr val="1F2A37"/>
+                </a:solidFill>
+                <a:latin typeface="Microsoft YaHei"/>
+              </a:rPr>
+              <a:t>· 门控并非永远无效：2025 年 Gotham-2025 语料上视图重合时差值恰为 0.000000，把 16 列压到 8 列、视图分化后增益 +0.0063（十个种子方向一致）。</a:t>
             </a:r>
           </a:p>
         </p:txBody>

</xml_diff>

<commit_message>
Round 20bg: three 2026 corpora (CTU-IDSEVAL-6, 6TiSCHSet-2026, RTN) - seventeen corpora span 1998-2026
</commit_message>
<xml_diff>
--- a/重构版论文_v4_20260915/汇报用_论文介绍.pptx
+++ b/重构版论文_v4_20260915/汇报用_论文介绍.pptx
@@ -6863,7 +6863,7 @@
                 </a:solidFill>
                 <a:latin typeface="Microsoft YaHei"/>
               </a:rPr>
-              <a:t>仓库：v1.11.0 标签 · 逐样本预测 722 个 · 补充材料 S01–S30 · 投稿包 884 个文件</a:t>
+              <a:t>仓库：v1.11.0 标签 · 逐样本预测 722 个 · 补充材料 S01–S30 · 投稿包 894 个文件</a:t>
             </a:r>
           </a:p>
         </p:txBody>
@@ -8008,7 +8008,7 @@
                 </a:solidFill>
                 <a:latin typeface="Microsoft YaHei"/>
               </a:rPr>
-              <a:t>六阶段审计 + 14 个语料 + 十个种子</a:t>
+              <a:t>六阶段审计 + 17 个语料 + 十个种子</a:t>
             </a:r>
           </a:p>
         </p:txBody>
@@ -13954,7 +13954,7 @@
                 </a:solidFill>
                 <a:latin typeface="Microsoft YaHei"/>
               </a:rPr>
-              <a:t>· 语料年代：14 个语料里八个发布于 2020 年及以后，其中四份发布于 2025 年，差值与上表同量级（见《向老师汇报要点》Q5）；</a:t>
+              <a:t>· 语料年代：17 个语料里八个发布于 2020 年及以后，其中四份发布于 2025 年，差值与上表同量级（见《向老师汇报要点》Q5）；</a:t>
             </a:r>
           </a:p>
           <a:p>

</xml_diff>

<commit_message>
Round 20bj: close the Round 20 documentation debt and refresh the meta layer - review report to Round 20, gap audit/self-check/work log, briefings and a 13-slide deck, Figure 12 (ladder), JISA abstract back under 250 words, tree-weight claim stated exactly, desktop-sync and archive scripts, memory guard; 53-check gate green
</commit_message>
<xml_diff>
--- a/重构版论文_v4_20260915/汇报用_论文介绍.pptx
+++ b/重构版论文_v4_20260915/汇报用_论文介绍.pptx
@@ -17,6 +17,7 @@
     <p:sldId id="265" r:id="rId17"/>
     <p:sldId id="266" r:id="rId18"/>
     <p:sldId id="267" r:id="rId19"/>
+    <p:sldId id="268" r:id="rId20"/>
   </p:sldIdLst>
   <p:sldSz cx="12191695" cy="6858000" type="screen4x3"/>
   <p:notesSz cx="6858000" cy="9144000"/>
@@ -724,6 +725,76 @@
           <a:p>
             <a:r>
               <a:t>这一页只在被问到复现性时使用：四条命令、检查覆盖的四类风险、以及五份可以当场打开的证据文档。</a:t>
+            </a:r>
+          </a:p>
+        </p:txBody>
+      </p:sp>
+      <p:sp>
+        <p:nvSpPr>
+          <p:cNvPr id="4" name="Slide Number Placeholder 3"/>
+          <p:cNvSpPr>
+            <a:spLocks noGrp="1"/>
+          </p:cNvSpPr>
+          <p:nvPr>
+            <p:ph type="sldNum" idx="5" sz="quarter"/>
+          </p:nvPr>
+        </p:nvSpPr>
+        <p:spPr/>
+      </p:sp>
+    </p:spTree>
+  </p:cSld>
+  <p:clrMapOvr>
+    <a:masterClrMapping/>
+  </p:clrMapOvr>
+</p:notes>
+</file>
+
+<file path=ppt/notesSlides/notesSlide13.xml><?xml version="1.0" encoding="utf-8"?>
+<p:notes xmlns:a="http://schemas.openxmlformats.org/drawingml/2006/main" xmlns:p="http://schemas.openxmlformats.org/presentationml/2006/main" xmlns:r="http://schemas.openxmlformats.org/officeDocument/2006/relationships">
+  <p:cSld>
+    <p:spTree>
+      <p:nvGrpSpPr>
+        <p:cNvPr id="1" name=""/>
+        <p:cNvGrpSpPr/>
+        <p:nvPr/>
+      </p:nvGrpSpPr>
+      <p:grpSpPr>
+        <a:xfrm>
+          <a:off x="0" y="0"/>
+          <a:ext cx="0" cy="0"/>
+          <a:chOff x="0" y="0"/>
+          <a:chExt cx="0" cy="0"/>
+        </a:xfrm>
+      </p:grpSpPr>
+      <p:sp>
+        <p:nvSpPr>
+          <p:cNvPr id="2" name="Slide Image Placeholder 1"/>
+          <p:cNvSpPr>
+            <a:spLocks noGrp="1"/>
+          </p:cNvSpPr>
+          <p:nvPr>
+            <p:ph type="sldImg" idx="2"/>
+          </p:nvPr>
+        </p:nvSpPr>
+        <p:spPr/>
+      </p:sp>
+      <p:sp>
+        <p:nvSpPr>
+          <p:cNvPr id="3" name="Notes Placeholder 2"/>
+          <p:cNvSpPr>
+            <a:spLocks noGrp="1"/>
+          </p:cNvSpPr>
+          <p:nvPr>
+            <p:ph type="body" idx="3" sz="quarter"/>
+          </p:nvPr>
+        </p:nvSpPr>
+        <p:spPr/>
+        <p:txBody>
+          <a:bodyPr/>
+          <a:lstStyle/>
+          <a:p>
+            <a:r>
+              <a:t>被问到「语料太老」时先讲这一页：规模、留出、预算扫描、机制四条证据，再把 k=8 的正例与「成员可互换性」连起来。</a:t>
             </a:r>
           </a:p>
         </p:txBody>
@@ -6863,7 +6934,7 @@
                 </a:solidFill>
                 <a:latin typeface="Microsoft YaHei"/>
               </a:rPr>
-              <a:t>仓库：v1.11.0 标签 · 逐样本预测 722 个 · 补充材料 S01–S30 · 投稿包 894 个文件</a:t>
+              <a:t>仓库：v1.11.0 标签 · 逐样本预测 722 个 · 补充材料 S01–S30 · 投稿包 916 个文件</a:t>
             </a:r>
           </a:p>
         </p:txBody>
@@ -7160,6 +7231,396 @@
                 <a:latin typeface="Microsoft YaHei"/>
               </a:rPr>
               <a:t>12</a:t>
+            </a:r>
+          </a:p>
+        </p:txBody>
+      </p:sp>
+    </p:spTree>
+  </p:cSld>
+  <p:clrMapOvr>
+    <a:masterClrMapping/>
+  </p:clrMapOvr>
+</p:sld>
+</file>
+
+<file path=ppt/slides/slide13.xml><?xml version="1.0" encoding="utf-8"?>
+<p:sld xmlns:a="http://schemas.openxmlformats.org/drawingml/2006/main" xmlns:p="http://schemas.openxmlformats.org/presentationml/2006/main" xmlns:r="http://schemas.openxmlformats.org/officeDocument/2006/relationships">
+  <p:cSld>
+    <p:spTree>
+      <p:nvGrpSpPr>
+        <p:cNvPr id="1" name=""/>
+        <p:cNvGrpSpPr/>
+        <p:nvPr/>
+      </p:nvGrpSpPr>
+      <p:grpSpPr/>
+      <p:sp>
+        <p:nvSpPr>
+          <p:cNvPr id="2" name="TextBox 1"/>
+          <p:cNvSpPr txBox="1"/>
+          <p:nvPr/>
+        </p:nvSpPr>
+        <p:spPr>
+          <a:xfrm>
+            <a:off x="548640" y="347472"/>
+            <a:ext cx="10972800" cy="310896"/>
+          </a:xfrm>
+          <a:prstGeom prst="rect">
+            <a:avLst/>
+          </a:prstGeom>
+          <a:noFill/>
+        </p:spPr>
+        <p:txBody>
+          <a:bodyPr wrap="square">
+            <a:spAutoFit/>
+          </a:bodyPr>
+          <a:lstStyle/>
+          <a:p>
+            <a:pPr algn="l">
+              <a:lnSpc>
+                <a:spcPct val="115000"/>
+              </a:lnSpc>
+            </a:pPr>
+            <a:r>
+              <a:rPr sz="1200" b="1">
+                <a:solidFill>
+                  <a:srgbClr val="1F6FEB"/>
+                </a:solidFill>
+                <a:latin typeface="Microsoft YaHei"/>
+              </a:rPr>
+              <a:t>附加页 · 2026-10-03 批次</a:t>
+            </a:r>
+          </a:p>
+        </p:txBody>
+      </p:sp>
+      <p:sp>
+        <p:nvSpPr>
+          <p:cNvPr id="3" name="TextBox 2"/>
+          <p:cNvSpPr txBox="1"/>
+          <p:nvPr/>
+        </p:nvSpPr>
+        <p:spPr>
+          <a:xfrm>
+            <a:off x="548640" y="694944"/>
+            <a:ext cx="11064240" cy="731520"/>
+          </a:xfrm>
+          <a:prstGeom prst="rect">
+            <a:avLst/>
+          </a:prstGeom>
+          <a:noFill/>
+        </p:spPr>
+        <p:txBody>
+          <a:bodyPr wrap="square">
+            <a:spAutoFit/>
+          </a:bodyPr>
+          <a:lstStyle/>
+          <a:p>
+            <a:pPr algn="l">
+              <a:lnSpc>
+                <a:spcPct val="115000"/>
+              </a:lnSpc>
+            </a:pPr>
+            <a:r>
+              <a:rPr sz="2600" b="1">
+                <a:solidFill>
+                  <a:srgbClr val="1F2A37"/>
+                </a:solidFill>
+                <a:latin typeface="Microsoft YaHei"/>
+              </a:rPr>
+              <a:t>现代语料阶梯：规模、分布位移与机制</a:t>
+            </a:r>
+          </a:p>
+        </p:txBody>
+      </p:sp>
+      <p:sp>
+        <p:nvSpPr>
+          <p:cNvPr id="4" name="Rectangle 3"/>
+          <p:cNvSpPr/>
+          <p:nvPr/>
+        </p:nvSpPr>
+        <p:spPr>
+          <a:xfrm>
+            <a:off x="548640" y="1463040"/>
+            <a:ext cx="11064240" cy="15240"/>
+          </a:xfrm>
+          <a:prstGeom prst="rect">
+            <a:avLst/>
+          </a:prstGeom>
+          <a:solidFill>
+            <a:srgbClr val="D1D5DB"/>
+          </a:solidFill>
+          <a:ln>
+            <a:noFill/>
+          </a:ln>
+          <a:effectLst/>
+        </p:spPr>
+        <p:style>
+          <a:lnRef idx="1">
+            <a:schemeClr val="accent1"/>
+          </a:lnRef>
+          <a:fillRef idx="3">
+            <a:schemeClr val="accent1"/>
+          </a:fillRef>
+          <a:effectRef idx="2">
+            <a:schemeClr val="accent1"/>
+          </a:effectRef>
+          <a:fontRef idx="minor">
+            <a:schemeClr val="lt1"/>
+          </a:fontRef>
+        </p:style>
+        <p:txBody>
+          <a:bodyPr rtlCol="0" anchor="ctr"/>
+          <a:lstStyle/>
+          <a:p>
+            <a:pPr algn="ctr"/>
+          </a:p>
+        </p:txBody>
+      </p:sp>
+      <p:sp>
+        <p:nvSpPr>
+          <p:cNvPr id="5" name="Rectangle 4"/>
+          <p:cNvSpPr/>
+          <p:nvPr/>
+        </p:nvSpPr>
+        <p:spPr>
+          <a:xfrm>
+            <a:off x="548640" y="1737360"/>
+            <a:ext cx="11064240" cy="3108960"/>
+          </a:xfrm>
+          <a:prstGeom prst="rect">
+            <a:avLst/>
+          </a:prstGeom>
+          <a:solidFill>
+            <a:srgbClr val="F3F5F7"/>
+          </a:solidFill>
+          <a:ln>
+            <a:solidFill>
+              <a:srgbClr val="F3F5F7"/>
+            </a:solidFill>
+          </a:ln>
+          <a:effectLst/>
+        </p:spPr>
+        <p:style>
+          <a:lnRef idx="1">
+            <a:schemeClr val="accent1"/>
+          </a:lnRef>
+          <a:fillRef idx="3">
+            <a:schemeClr val="accent1"/>
+          </a:fillRef>
+          <a:effectRef idx="2">
+            <a:schemeClr val="accent1"/>
+          </a:effectRef>
+          <a:fontRef idx="minor">
+            <a:schemeClr val="lt1"/>
+          </a:fontRef>
+        </p:style>
+        <p:txBody>
+          <a:bodyPr rtlCol="0" anchor="ctr"/>
+          <a:lstStyle/>
+          <a:p>
+            <a:pPr algn="ctr"/>
+          </a:p>
+        </p:txBody>
+      </p:sp>
+      <p:sp>
+        <p:nvSpPr>
+          <p:cNvPr id="6" name="TextBox 5"/>
+          <p:cNvSpPr txBox="1"/>
+          <p:nvPr/>
+        </p:nvSpPr>
+        <p:spPr>
+          <a:xfrm>
+            <a:off x="822960" y="1920240"/>
+            <a:ext cx="10515600" cy="2743200"/>
+          </a:xfrm>
+          <a:prstGeom prst="rect">
+            <a:avLst/>
+          </a:prstGeom>
+          <a:noFill/>
+        </p:spPr>
+        <p:txBody>
+          <a:bodyPr wrap="square">
+            <a:spAutoFit/>
+          </a:bodyPr>
+          <a:lstStyle/>
+          <a:p>
+            <a:pPr algn="l">
+              <a:lnSpc>
+                <a:spcPct val="135000"/>
+              </a:lnSpc>
+            </a:pPr>
+            <a:r>
+              <a:rPr sz="1400" b="0">
+                <a:solidFill>
+                  <a:srgbClr val="1F2A37"/>
+                </a:solidFill>
+                <a:latin typeface="Microsoft YaHei"/>
+              </a:rPr>
+              <a:t>规模：CIC-IoT-2023 每类 20 万 −0.000021 / 每类 50 万 −0.000004；Gotham-2025 每类 20 万 +0.000011 / 不限上限（7 189 693 行）+0.000009。</a:t>
+            </a:r>
+          </a:p>
+          <a:p>
+            <a:pPr algn="l">
+              <a:lnSpc>
+                <a:spcPct val="135000"/>
+              </a:lnSpc>
+            </a:pPr>
+            <a:r>
+              <a:rPr sz="1400" b="0">
+                <a:solidFill>
+                  <a:srgbClr val="1F2A37"/>
+                </a:solidFill>
+                <a:latin typeface="Microsoft YaHei"/>
+              </a:rPr>
+              <a:t>分布位移：Gotham 逐设备留出 12/78 台，RCCF 均值 0.9671，两臂差 +0.000000；6TiSCHSet 逐运行留出 12/122 次，均值 0.5223，两臂差 +0.000123。</a:t>
+            </a:r>
+          </a:p>
+          <a:p>
+            <a:pPr algn="l">
+              <a:lnSpc>
+                <a:spcPct val="135000"/>
+              </a:lnSpc>
+            </a:pPr>
+            <a:r>
+              <a:rPr sz="1400" b="0">
+                <a:solidFill>
+                  <a:srgbClr val="1F2A37"/>
+                </a:solidFill>
+                <a:latin typeface="Microsoft YaHei"/>
+              </a:rPr>
+              <a:t>剂量—反应：特征预算 k=8 +0.001663 → k=16 +0.000402 → k=32 −0.000002 → k=60 −0.000004。</a:t>
+            </a:r>
+          </a:p>
+          <a:p>
+            <a:pPr algn="l">
+              <a:lnSpc>
+                <a:spcPct val="135000"/>
+              </a:lnSpc>
+            </a:pPr>
+            <a:r>
+              <a:rPr sz="1400" b="0">
+                <a:solidFill>
+                  <a:srgbClr val="1F2A37"/>
+                </a:solidFill>
+                <a:latin typeface="Microsoft YaHei"/>
+              </a:rPr>
+              <a:t>机制：Gotham 全档改判 0/297 180 行；CIC-IoT-2023 改判 12/375 160 行（理论界可证 99.45%）；树权重落在 0.0091–0.0102 之间；增益与分歧回归 r = 0.744。</a:t>
+            </a:r>
+          </a:p>
+        </p:txBody>
+      </p:sp>
+      <p:sp>
+        <p:nvSpPr>
+          <p:cNvPr id="7" name="TextBox 6"/>
+          <p:cNvSpPr txBox="1"/>
+          <p:nvPr/>
+        </p:nvSpPr>
+        <p:spPr>
+          <a:xfrm>
+            <a:off x="822960" y="5029200"/>
+            <a:ext cx="10515600" cy="1097280"/>
+          </a:xfrm>
+          <a:prstGeom prst="rect">
+            <a:avLst/>
+          </a:prstGeom>
+          <a:noFill/>
+        </p:spPr>
+        <p:txBody>
+          <a:bodyPr wrap="square">
+            <a:spAutoFit/>
+          </a:bodyPr>
+          <a:lstStyle/>
+          <a:p>
+            <a:pPr algn="l">
+              <a:lnSpc>
+                <a:spcPct val="130000"/>
+              </a:lnSpc>
+            </a:pPr>
+            <a:r>
+              <a:rPr sz="1300" b="0">
+                <a:solidFill>
+                  <a:srgbClr val="6B7280"/>
+                </a:solidFill>
+                <a:latin typeface="Microsoft YaHei"/>
+              </a:rPr>
+              <a:t>一句话：2017 语料上那个 −0.005533 的规模性劣势没有在现代语料上复现；决定等价性的是成员可互换性，而不是语料年代或训练规模。</a:t>
+            </a:r>
+          </a:p>
+        </p:txBody>
+      </p:sp>
+      <p:sp>
+        <p:nvSpPr>
+          <p:cNvPr id="8" name="TextBox 7"/>
+          <p:cNvSpPr txBox="1"/>
+          <p:nvPr/>
+        </p:nvSpPr>
+        <p:spPr>
+          <a:xfrm>
+            <a:off x="548640" y="6400800"/>
+            <a:ext cx="8229600" cy="274320"/>
+          </a:xfrm>
+          <a:prstGeom prst="rect">
+            <a:avLst/>
+          </a:prstGeom>
+          <a:noFill/>
+        </p:spPr>
+        <p:txBody>
+          <a:bodyPr wrap="square">
+            <a:spAutoFit/>
+          </a:bodyPr>
+          <a:lstStyle/>
+          <a:p>
+            <a:pPr algn="l">
+              <a:lnSpc>
+                <a:spcPct val="115000"/>
+              </a:lnSpc>
+            </a:pPr>
+            <a:r>
+              <a:rPr sz="1000" b="0">
+                <a:solidFill>
+                  <a:srgbClr val="6B7280"/>
+                </a:solidFill>
+                <a:latin typeface="Microsoft YaHei"/>
+              </a:rPr>
+              <a:t>泄漏受控的条件集成加权研究 · v1.11.0 · 数字均取自发布产物</a:t>
+            </a:r>
+          </a:p>
+        </p:txBody>
+      </p:sp>
+      <p:sp>
+        <p:nvSpPr>
+          <p:cNvPr id="9" name="TextBox 8"/>
+          <p:cNvSpPr txBox="1"/>
+          <p:nvPr/>
+        </p:nvSpPr>
+        <p:spPr>
+          <a:xfrm>
+            <a:off x="11155680" y="6400800"/>
+            <a:ext cx="548640" cy="274320"/>
+          </a:xfrm>
+          <a:prstGeom prst="rect">
+            <a:avLst/>
+          </a:prstGeom>
+          <a:noFill/>
+        </p:spPr>
+        <p:txBody>
+          <a:bodyPr wrap="square">
+            <a:spAutoFit/>
+          </a:bodyPr>
+          <a:lstStyle/>
+          <a:p>
+            <a:pPr algn="r">
+              <a:lnSpc>
+                <a:spcPct val="115000"/>
+              </a:lnSpc>
+            </a:pPr>
+            <a:r>
+              <a:rPr sz="1000" b="0">
+                <a:solidFill>
+                  <a:srgbClr val="6B7280"/>
+                </a:solidFill>
+                <a:latin typeface="Microsoft YaHei"/>
+              </a:rPr>
+              <a:t>13</a:t>
             </a:r>
           </a:p>
         </p:txBody>

</xml_diff>